<commit_message>
fix + audit: LLM resolver bug, honest preflight, 138 tests in claims
- agent/_resolve_model now ranks only the google/ namespace (the gateway's
  48-id list includes bytedance/doubao-seedream — a video model the resolver
  picked, so the LLM answer 404'd on vertex). New regression tests.
- Server .env → GEMINI_MODEL=google/gemini-3.1-flash-lite; deployed.
- Readiness audit: re-verified every headline claim live. "342 of 2,098" was
  actually correct (UI payload); 105→138 tests across deck, one-pager, README,
  pitch, brief; deck/one-pager PDFs rebuilt; deck foot updated to honest state.
- Preflight READY — agent answers by real Gemini, two honest warnings.
</commit_message>
<xml_diff>
--- a/submission/CarbonPilot_submission_deck.pptx
+++ b/submission/CarbonPilot_submission_deck.pptx
@@ -5696,7 +5696,7 @@
                 </a:solidFill>
                 <a:latin typeface="IBM Plex Mono"/>
               </a:rPr>
-              <a:t>105</a:t>
+              <a:t>138</a:t>
             </a:r>
           </a:p>
         </p:txBody>
@@ -12869,7 +12869,7 @@
                 </a:solidFill>
                 <a:latin typeface="Source Serif 4"/>
               </a:rPr>
-              <a:t>105 tests. A smoke test that fails on a working-looking key. One process.</a:t>
+              <a:t>138 tests. A smoke test that fails on a working-looking key. One process.</a:t>
             </a:r>
           </a:p>
         </p:txBody>
@@ -13023,7 +13023,7 @@
                 </a:solidFill>
                 <a:latin typeface="Inter"/>
               </a:rPr>
-              <a:t>A projection plus its saving equals the baseline. Constraint search only ever returns scenarios that satisfy the constraints. 105 tests, runnable without credentials.</a:t>
+              <a:t>A projection plus its saving equals the baseline. Constraint search only ever returns scenarios that satisfy the constraints. 138 tests, runnable without credentials.</a:t>
             </a:r>
           </a:p>
         </p:txBody>
@@ -13326,7 +13326,7 @@
                 </a:solidFill>
                 <a:latin typeface="Inter"/>
               </a:rPr>
-              <a:t>Verified 2026-10-04: backend 32s · frontend typecheck + static export ~1 min · preflight READY, 13 OK.</a:t>
+              <a:t>Verified 2026-10-15: backend 36s · frontend typecheck + static export ~1 min · preflight READY — agent answers by real Gemini; two honest warnings: 16 approved actions on the plan, curated-only factors (no Climatiq key).</a:t>
             </a:r>
           </a:p>
         </p:txBody>

</xml_diff>